<commit_message>
UDP used DNS Look up_Looking for IP Address from Root Name Servers
</commit_message>
<xml_diff>
--- a/network/sir-slides/2. Networking_Protocols_Deep_Dive_PDS_Light_Earthy.pptx
+++ b/network/sir-slides/2. Networking_Protocols_Deep_Dive_PDS_Light_Earthy.pptx
@@ -7933,9 +7933,42 @@
                 <a:ea typeface="Quattrocento Sans" pitchFamily="34" charset="-122"/>
                 <a:cs typeface="Quattrocento Sans" pitchFamily="34" charset="-120"/>
               </a:rPr>
-              <a:t>✓ Server acknowledges: Ack = 3921 (2461 + 1460)</a:t>
+              <a:t>✓ </a:t>
             </a:r>
-            <a:endParaRPr lang="en-US" sz="1600" dirty="0"/>
+            <a:r>
+              <a:rPr lang="en-US" sz="1050" b="1" dirty="0">
+                <a:solidFill>
+                  <a:srgbClr val="9C8C7A"/>
+                </a:solidFill>
+                <a:latin typeface="Quattrocento Sans" pitchFamily="34" charset="0"/>
+                <a:ea typeface="Quattrocento Sans" pitchFamily="34" charset="-122"/>
+                <a:cs typeface="Quattrocento Sans" pitchFamily="34" charset="-120"/>
+              </a:rPr>
+              <a:t>Server acknowledges: Ack </a:t>
+            </a:r>
+            <a:r>
+              <a:rPr lang="en-US" sz="1050" dirty="0">
+                <a:solidFill>
+                  <a:srgbClr val="9C8C7A"/>
+                </a:solidFill>
+                <a:latin typeface="Quattrocento Sans" pitchFamily="34" charset="0"/>
+                <a:ea typeface="Quattrocento Sans" pitchFamily="34" charset="-122"/>
+                <a:cs typeface="Quattrocento Sans" pitchFamily="34" charset="-120"/>
+              </a:rPr>
+              <a:t>= 3921 (2461 + 1460</a:t>
+            </a:r>
+            <a:r>
+              <a:rPr lang="en-US" sz="1050" b="1" dirty="0">
+                <a:solidFill>
+                  <a:srgbClr val="9C8C7A"/>
+                </a:solidFill>
+                <a:latin typeface="Quattrocento Sans" pitchFamily="34" charset="0"/>
+                <a:ea typeface="Quattrocento Sans" pitchFamily="34" charset="-122"/>
+                <a:cs typeface="Quattrocento Sans" pitchFamily="34" charset="-120"/>
+              </a:rPr>
+              <a:t>)</a:t>
+            </a:r>
+            <a:endParaRPr lang="en-US" sz="1600" b="1" dirty="0"/>
           </a:p>
         </p:txBody>
       </p:sp>
@@ -12891,7 +12924,7 @@
         </p:nvSpPr>
         <p:spPr>
           <a:xfrm>
-            <a:off x="561975" y="5229225"/>
+            <a:off x="590550" y="5229225"/>
             <a:ext cx="5295900" cy="647700"/>
           </a:xfrm>
           <a:custGeom>
@@ -36850,9 +36883,22 @@
                 <a:ea typeface="Quattrocento Sans" pitchFamily="34" charset="-122"/>
                 <a:cs typeface="Quattrocento Sans" pitchFamily="34" charset="-120"/>
               </a:rPr>
-              <a:t>Every TCP segment contains a header (20-60 bytes) with control information</a:t>
+              <a:t>Every TCP segment contains a </a:t>
             </a:r>
-            <a:endParaRPr lang="en-US" sz="1600" dirty="0"/>
+            <a:r>
+              <a:rPr lang="en-US" sz="1096" b="1" dirty="0">
+                <a:solidFill>
+                  <a:srgbClr val="4A3F35">
+                    <a:alpha val="60000"/>
+                  </a:srgbClr>
+                </a:solidFill>
+                <a:latin typeface="Quattrocento Sans" pitchFamily="34" charset="0"/>
+                <a:ea typeface="Quattrocento Sans" pitchFamily="34" charset="-122"/>
+                <a:cs typeface="Quattrocento Sans" pitchFamily="34" charset="-120"/>
+              </a:rPr>
+              <a:t>header (20-60 bytes) with control information</a:t>
+            </a:r>
+            <a:endParaRPr lang="en-US" sz="1600" b="1" dirty="0"/>
           </a:p>
         </p:txBody>
       </p:sp>
@@ -40284,7 +40330,7 @@
         <p:spPr>
           <a:xfrm>
             <a:off x="6870374" y="4233696"/>
-            <a:ext cx="4969045" cy="670081"/>
+            <a:ext cx="4969045" cy="1074741"/>
           </a:xfrm>
           <a:custGeom>
             <a:avLst/>
@@ -40525,7 +40571,7 @@
               </a:lnSpc>
             </a:pPr>
             <a:r>
-              <a:rPr lang="en-US" sz="1096" b="1" dirty="0">
+              <a:rPr lang="en-US" b="1" dirty="0">
                 <a:solidFill>
                   <a:srgbClr val="4A3F35"/>
                 </a:solidFill>
@@ -40535,7 +40581,7 @@
               </a:rPr>
               <a:t>Header Size</a:t>
             </a:r>
-            <a:endParaRPr lang="en-US" sz="1600" dirty="0"/>
+            <a:endParaRPr lang="en-US" sz="3200" dirty="0"/>
           </a:p>
         </p:txBody>
       </p:sp>
@@ -40547,7 +40593,7 @@
         </p:nvSpPr>
         <p:spPr>
           <a:xfrm>
-            <a:off x="7335950" y="4586141"/>
+            <a:off x="7344652" y="4784121"/>
             <a:ext cx="3158955" cy="174047"/>
           </a:xfrm>
           <a:prstGeom prst="rect">
@@ -40566,7 +40612,7 @@
               </a:lnSpc>
             </a:pPr>
             <a:r>
-              <a:rPr lang="en-US" sz="959" dirty="0">
+              <a:rPr lang="en-US" sz="1400" dirty="0">
                 <a:solidFill>
                   <a:srgbClr val="4A3F35">
                     <a:alpha val="80000"/>
@@ -40579,7 +40625,7 @@
               <a:t>Varies from </a:t>
             </a:r>
             <a:r>
-              <a:rPr lang="en-US" sz="959" b="1" dirty="0">
+              <a:rPr lang="en-US" sz="1400" b="1" dirty="0">
                 <a:solidFill>
                   <a:srgbClr val="BD6B4F"/>
                 </a:solidFill>
@@ -40590,7 +40636,7 @@
               <a:t>20 bytes</a:t>
             </a:r>
             <a:r>
-              <a:rPr lang="en-US" sz="959" dirty="0">
+              <a:rPr lang="en-US" sz="1400" dirty="0">
                 <a:solidFill>
                   <a:srgbClr val="4A3F35">
                     <a:alpha val="80000"/>
@@ -40603,7 +40649,7 @@
               <a:t> (minimum) to </a:t>
             </a:r>
             <a:r>
-              <a:rPr lang="en-US" sz="959" b="1" dirty="0">
+              <a:rPr lang="en-US" sz="1400" b="1" dirty="0">
                 <a:solidFill>
                   <a:srgbClr val="BD6B4F"/>
                 </a:solidFill>
@@ -40614,7 +40660,7 @@
               <a:t>60 bytes</a:t>
             </a:r>
             <a:r>
-              <a:rPr lang="en-US" sz="959" dirty="0">
+              <a:rPr lang="en-US" sz="1400" dirty="0">
                 <a:solidFill>
                   <a:srgbClr val="4A3F35">
                     <a:alpha val="80000"/>
@@ -40626,7 +40672,7 @@
               </a:rPr>
               <a:t> (with options)</a:t>
             </a:r>
-            <a:endParaRPr lang="en-US" sz="1600" dirty="0"/>
+            <a:endParaRPr lang="en-US" sz="3200" dirty="0"/>
           </a:p>
         </p:txBody>
       </p:sp>

</xml_diff>